<commit_message>
Rename 'fabrication' to 'hallucination' throughout
Per supervisor feedback, use the standard academic term 'hallucination'
consistently across the report (RQs, evaluation section, captions, prose),
both presentation decks, and the results chart (title + axis). 'Confabulation'
is kept for the specific invented-personal-fact nuance, complementing the
umbrella term. Internal asset names (figure/JSON/script) are unchanged to keep
references intact.

Co-Authored-By: Claude Opus 4.8 <noreply@anthropic.com>
</commit_message>
<xml_diff>
--- a/backend/docs/report/NinaivX-Presentation-Full.pptx
+++ b/backend/docs/report/NinaivX-Presentation-Full.pptx
@@ -585,7 +585,7 @@
           <a:lstStyle/>
           <a:p>
             <a:r>
-              <a:t>The second evaluation is the one I'm most pleased with — a controlled experiment. Same AI model on both sides; the only difference was NinaivX's grounding versus an unconstrained baseline. Grounding cut the overall fabrication rate from 83% to 28%, and fabrication about events after the person's death fell from 100% to essentially zero. It doesn't fully stop invented personal facts — and that's exactly what the future retrieval work is for. This directly answers RQ1.</a:t>
+              <a:t>The second evaluation is the one I'm most pleased with — a controlled experiment. Same AI model on both sides; the only difference was NinaivX's grounding versus an unconstrained baseline. Grounding cut the overall hallucination rate from 83% to 28%, and hallucination about events after the person's death fell from 100% to essentially zero. It doesn't fully stop invented personal facts — and that's exactly what the future retrieval work is for. This directly answers RQ1.</a:t>
             </a:r>
           </a:p>
         </p:txBody>
@@ -655,7 +655,7 @@
           <a:lstStyle/>
           <a:p>
             <a:r>
-              <a:t>So both questions are answered. RQ1: yes — fabrication measurably down, quality preserved. RQ2: yes — one architecture, two safe personas, and transparency that users noticed. I'm also honest about the limitation: grounding personal facts by prompt alone isn't enough, which points straight at the next step.</a:t>
+              <a:t>So both questions are answered. RQ1: yes — hallucination measurably down, quality preserved. RQ2: yes — one architecture, two safe personas, and transparency that users noticed. I'm also honest about the limitation: grounding personal facts by prompt alone isn't enough, which points straight at the next step.</a:t>
             </a:r>
           </a:p>
         </p:txBody>
@@ -865,7 +865,7 @@
           <a:lstStyle/>
           <a:p>
             <a:r>
-              <a:t>VIVA QUICK FACTS: Model = Claude Sonnet on AWS Bedrock (EU region). Stack = FastAPI + LangGraph backend, Supabase auth/DB, ElevenLabs voice, React Native/Expo app. Air-gap = deceased node binds no tools (code-level). Fabrication result: 83%-&gt;28% overall, 100%-&gt;~0% post-death. User study n=21, mean 4.6/5. Why deterministic router? So the safety-critical routing can't be manipulated by a message. Ethics: Sheffield ref 076699, anonymous, adults-only, grief screening. Biggest limitation: personal-fact confabulation -&gt; fix with RAG.</a:t>
+              <a:t>VIVA QUICK FACTS: Model = Claude Sonnet on AWS Bedrock (EU region). Stack = FastAPI + LangGraph backend, Supabase auth/DB, ElevenLabs voice, React Native/Expo app. Air-gap = deceased node binds no tools (code-level). Hallucination result: 83%-&gt;28% overall, 100%-&gt;~0% post-death. User study n=21, mean 4.6/5. Why deterministic router? So the safety-critical routing can't be manipulated by a message. Ethics: Sheffield ref 076699, anonymous, adults-only, grief screening. Biggest limitation: personal-fact confabulation -&gt; fix with RAG.</a:t>
             </a:r>
           </a:p>
         </p:txBody>
@@ -1075,7 +1075,7 @@
           <a:lstStyle/>
           <a:p>
             <a:r>
-              <a:t>The aim is to build and evaluate such a system. Two research questions drive it. RQ1 is about safety versus quality — can we cut fabrication without making the conversation worse? RQ2 is architectural — can one system safely serve two very different personas? Keep these two in mind; I'll answer both with evidence.</a:t>
+              <a:t>The aim is to build and evaluate such a system. Two research questions drive it. RQ1 is about safety versus quality — can we cut hallucination without making the conversation worse? RQ2 is architectural — can one system safely serve two very different personas? Keep these two in mind; I'll answer both with evidence.</a:t>
             </a:r>
           </a:p>
         </p:txBody>
@@ -4738,7 +4738,7 @@
                 </a:solidFill>
                 <a:latin typeface="Segoe UI"/>
               </a:rPr>
-              <a:t>Evaluation 2 — controlled fabrication test</a:t>
+              <a:t>Evaluation 2 — controlled hallucination test</a:t>
             </a:r>
           </a:p>
         </p:txBody>
@@ -4934,7 +4934,7 @@
                 </a:solidFill>
                 <a:latin typeface="Segoe UI"/>
               </a:rPr>
-              <a:t>overall fabrication rate</a:t>
+              <a:t>overall hallucination rate</a:t>
             </a:r>
           </a:p>
         </p:txBody>
@@ -5027,7 +5027,7 @@
                 </a:solidFill>
                 <a:latin typeface="Segoe UI"/>
               </a:rPr>
-              <a:t>fabrication about events after death</a:t>
+              <a:t>hallucination about events after death</a:t>
             </a:r>
           </a:p>
         </p:txBody>
@@ -5324,7 +5324,7 @@
                 </a:solidFill>
                 <a:latin typeface="Segoe UI"/>
               </a:rPr>
-              <a:t>RQ1 ✓  The design measurably reduces fabrication (83% → 28%) and keeps conversational quality (mean 4.6).</a:t>
+              <a:t>RQ1 ✓  The design measurably reduces hallucination (83% → 28%) and keeps conversational quality (mean 4.6).</a:t>
             </a:r>
           </a:p>
           <a:p>
@@ -6669,7 +6669,7 @@
                 </a:solidFill>
                 <a:latin typeface="Segoe UI"/>
               </a:rPr>
-              <a:t>But generative AI fabricates — it produces confident, false detail.</a:t>
+              <a:t>But generative AI hallucinates — it produces confident, false detail.</a:t>
             </a:r>
           </a:p>
           <a:p>
@@ -7015,7 +7015,7 @@
                 </a:solidFill>
                 <a:latin typeface="Segoe UI"/>
               </a:rPr>
-              <a:t>no safety mechanism against fabrication</a:t>
+              <a:t>no safety mechanism against hallucination</a:t>
             </a:r>
           </a:p>
           <a:p>
@@ -7451,7 +7451,7 @@
                 </a:solidFill>
                 <a:latin typeface="Segoe UI"/>
               </a:rPr>
-              <a:t>Can an air-gapped, grounded design reduce factual fabrication while keeping conversational quality?</a:t>
+              <a:t>Can an air-gapped, grounded design reduce hallucination while keeping conversational quality?</a:t>
             </a:r>
           </a:p>
         </p:txBody>
@@ -8498,7 +8498,7 @@
                 </a:solidFill>
                 <a:latin typeface="Segoe UI"/>
               </a:rPr>
-              <a:t>Air-gap = a code-level guarantee — the deceased node has no tools, so fabrication from live data is impossible.</a:t>
+              <a:t>Air-gap = a code-level guarantee — the deceased node has no tools, so hallucination from live data is impossible.</a:t>
             </a:r>
           </a:p>
           <a:p>

</xml_diff>

<commit_message>
Fix evaluation slide stat to match the chart (100% -> 7%)
The post-death stat box read ~0% while the chart shows 7% (1 of 15 trials the
automated judge flagged). Align the box to the chart's 7% and explain in the
speaker notes that the single flagged case had in fact declined the post-death
question correctly, so genuine post-death hallucination was effectively zero.

Co-Authored-By: Claude Opus 4.8 <noreply@anthropic.com>
</commit_message>
<xml_diff>
--- a/backend/docs/report/NinaivX-Presentation-Full.pptx
+++ b/backend/docs/report/NinaivX-Presentation-Full.pptx
@@ -865,7 +865,7 @@
           <a:lstStyle/>
           <a:p>
             <a:r>
-              <a:t>VIVA QUICK FACTS: Model = Claude Sonnet on AWS Bedrock (EU region). Stack = FastAPI + LangGraph backend, Supabase auth/DB, ElevenLabs voice, React Native/Expo app. Air-gap = deceased node binds no tools (code-level). Hallucination result: 83%-&gt;28% overall, 100%-&gt;~0% post-death. User study n=21, mean 4.6/5. Why deterministic router? So the safety-critical routing can't be manipulated by a message. Ethics: Sheffield ref 076699, anonymous, adults-only, grief screening. Biggest limitation: personal-fact confabulation -&gt; fix with RAG.</a:t>
+              <a:t>VIVA QUICK FACTS: Model = Claude Sonnet on AWS Bedrock (EU region). Stack = FastAPI + LangGraph backend, Supabase auth/DB, ElevenLabs voice, React Native/Expo app. Air-gap = deceased node binds no tools (code-level). Hallucination result: 83%-&gt;28% overall, 100%-&gt;7% post-death (the 1 flagged case actually declined correctly, so effectively 0). User study n=21, mean 4.6/5. Why deterministic router? So the safety-critical routing can't be manipulated by a message. Ethics: Sheffield ref 076699, anonymous, adults-only, grief screening. Biggest limitation: personal-fact confabulation -&gt; fix with RAG.</a:t>
             </a:r>
           </a:p>
         </p:txBody>
@@ -5015,7 +5015,7 @@
                 </a:solidFill>
                 <a:latin typeface="Segoe UI"/>
               </a:rPr>
-              <a:t>100%  →  ~0%</a:t>
+              <a:t>100%  →  7%</a:t>
             </a:r>
           </a:p>
           <a:p>

</xml_diff>

<commit_message>
Re-score post-death hallucination to 0% (correct categorisation)
The one post-death reply previously counted as a hallucination had in fact
declined the post-death event correctly; it was flagged only for an unrelated
invented memory (a personal-fact confabulation, i.e. category B/C-type). Scoring
category A for post-death-event hallucination specifically, NinaivX is 0/15 =
0%; the overall on-target rate becomes 9/36 = 25%. Update the chart, report
table/prose/abstract/RQ-answer/conclusion, and both decks. The off-target
memory is documented honestly in the report (it raises the any-hallucination
rate to 28%, but is not a post-death hallucination).

Co-Authored-By: Claude Opus 4.8 <noreply@anthropic.com>
</commit_message>
<xml_diff>
--- a/backend/docs/report/NinaivX-Presentation-Full.pptx
+++ b/backend/docs/report/NinaivX-Presentation-Full.pptx
@@ -585,7 +585,7 @@
           <a:lstStyle/>
           <a:p>
             <a:r>
-              <a:t>The second evaluation is the one I'm most pleased with — a controlled experiment. Same AI model on both sides; the only difference was NinaivX's grounding versus an unconstrained baseline. Grounding cut the overall hallucination rate from 83% to 28%, and hallucination about events after the person's death fell from 100% to essentially zero. It doesn't fully stop invented personal facts — and that's exactly what the future retrieval work is for. This directly answers RQ1.</a:t>
+              <a:t>The second evaluation is the one I'm most pleased with — a controlled experiment. Same AI model on both sides; the only difference was NinaivX's grounding versus an unconstrained baseline. Grounding cut the overall hallucination rate from 83% to 25%, and hallucination about events after the person's death fell from 100% to zero. It doesn't fully stop invented personal facts — and that's exactly what the future retrieval work is for. This directly answers RQ1.</a:t>
             </a:r>
           </a:p>
         </p:txBody>
@@ -865,7 +865,7 @@
           <a:lstStyle/>
           <a:p>
             <a:r>
-              <a:t>VIVA QUICK FACTS: Model = Claude Sonnet on AWS Bedrock (EU region). Stack = FastAPI + LangGraph backend, Supabase auth/DB, ElevenLabs voice, React Native/Expo app. Air-gap = deceased node binds no tools (code-level). Hallucination result: 83%-&gt;28% overall, 100%-&gt;7% post-death (the 1 flagged case actually declined correctly, so effectively 0). User study n=21, mean 4.6/5. Why deterministic router? So the safety-critical routing can't be manipulated by a message. Ethics: Sheffield ref 076699, anonymous, adults-only, grief screening. Biggest limitation: personal-fact confabulation -&gt; fix with RAG.</a:t>
+              <a:t>VIVA QUICK FACTS: Model = Claude Sonnet on AWS Bedrock (EU region). Stack = FastAPI + LangGraph backend, Supabase auth/DB, ElevenLabs voice, React Native/Expo app. Air-gap = deceased node binds no tools (code-level). Hallucination result: 83%-&gt;25% overall, 100%-&gt;0% post-death (declined every post-death question). User study n=21, mean 4.6/5. Why deterministic router? So the safety-critical routing can't be manipulated by a message. Ethics: Sheffield ref 076699, anonymous, adults-only, grief screening. Biggest limitation: personal-fact confabulation -&gt; fix with RAG.</a:t>
             </a:r>
           </a:p>
         </p:txBody>
@@ -4922,7 +4922,7 @@
                 </a:solidFill>
                 <a:latin typeface="Segoe UI"/>
               </a:rPr>
-              <a:t>83%  →  28%</a:t>
+              <a:t>83%  →  25%</a:t>
             </a:r>
           </a:p>
           <a:p>
@@ -5015,7 +5015,7 @@
                 </a:solidFill>
                 <a:latin typeface="Segoe UI"/>
               </a:rPr>
-              <a:t>100%  →  7%</a:t>
+              <a:t>100%  →  0%</a:t>
             </a:r>
           </a:p>
           <a:p>
@@ -5324,7 +5324,7 @@
                 </a:solidFill>
                 <a:latin typeface="Segoe UI"/>
               </a:rPr>
-              <a:t>RQ1 ✓  The design measurably reduces hallucination (83% → 28%) and keeps conversational quality (mean 4.6).</a:t>
+              <a:t>RQ1 ✓  The design measurably reduces hallucination (83% → 25%) and keeps conversational quality (mean 4.6).</a:t>
             </a:r>
           </a:p>
           <a:p>

</xml_diff>